<commit_message>
Fixed theedge cases during the  setup process
</commit_message>
<xml_diff>
--- a/docs/presentations/ai-assisted-development-story.pptx
+++ b/docs/presentations/ai-assisted-development-story.pptx
@@ -154,14 +154,6 @@
     </p:ext>
   </p:extLst>
 </p:presentation>
-</file>
-
-<file path=ppt/revisionInfo.xml><?xml version="1.0" encoding="utf-8"?>
-<p1510:revInfo xmlns:a="http://schemas.openxmlformats.org/drawingml/2006/main" xmlns:r="http://schemas.openxmlformats.org/officeDocument/2006/relationships" xmlns:p1510="http://schemas.microsoft.com/office/powerpoint/2015/10/main">
-  <p1510:revLst>
-    <p1510:client id="{3C73BF7C-5CFF-47DF-BA55-A3DD79C44D2D}" v="13" dt="2026-07-17T19:07:53.175"/>
-  </p1510:revLst>
-</p1510:revInfo>
 </file>
 
 <file path=ppt/notesMasters/notesMaster1.xml><?xml version="1.0" encoding="utf-8"?>
@@ -37190,24 +37182,24 @@
         </p:nvSpPr>
         <p:spPr>
           <a:xfrm>
-            <a:off x="548640" y="5806440"/>
-            <a:ext cx="10972800" cy="320040"/>
-          </a:xfrm>
-          <a:prstGeom prst="rect">
-            <a:avLst/>
-          </a:prstGeom>
-          <a:noFill/>
-          <a:ln/>
-        </p:spPr>
-        <p:txBody>
-          <a:bodyPr wrap="square" rtlCol="0" anchor="ctr"/>
-          <a:lstStyle/>
-          <a:p>
-            <a:pPr marL="0" indent="0">
-              <a:buNone/>
-            </a:pPr>
-            <a:r>
-              <a:rPr lang="en-US" sz="1400" dirty="0">
+            <a:off x="0" y="5806440"/>
+            <a:ext cx="12192000" cy="594360"/>
+          </a:xfrm>
+          <a:prstGeom prst="rect">
+            <a:avLst/>
+          </a:prstGeom>
+          <a:noFill/>
+          <a:ln/>
+        </p:spPr>
+        <p:txBody>
+          <a:bodyPr wrap="square" rtlCol="0" anchor="ctr"/>
+          <a:lstStyle/>
+          <a:p>
+            <a:pPr marL="0" indent="0" algn="ctr">
+              <a:buNone/>
+            </a:pPr>
+            <a:r>
+              <a:rPr lang="en-US" sz="4400" b="1" dirty="0">
                 <a:solidFill>
                   <a:srgbClr val="9DB2C7"/>
                 </a:solidFill>
@@ -37215,9 +37207,9 @@
                 <a:ea typeface="Segoe UI" pitchFamily="34" charset="-122"/>
                 <a:cs typeface="Segoe UI" pitchFamily="34" charset="-120"/>
               </a:rPr>
-              <a:t>Discussion.</a:t>
-            </a:r>
-            <a:endParaRPr lang="en-US" sz="1400" dirty="0"/>
+              <a:t>Q &amp; A</a:t>
+            </a:r>
+            <a:endParaRPr lang="en-US" sz="4400" b="1" dirty="0"/>
           </a:p>
         </p:txBody>
       </p:sp>

</xml_diff>